<commit_message>
feat: add layers visibility and project autosave
</commit_message>
<xml_diff>
--- a/examples/usa-map-studio-editable-export.pptx
+++ b/examples/usa-map-studio-editable-export.pptx
@@ -505,7 +505,9 @@
               <a:t>[Sources]
 Boundary and place-coordinate data: U.S. Census Bureau 2025 Cartographic Boundary and Gazetteer files.
 Map composition: USA Map Studio project export.
-Editability: states, boundary layers, text, standard pins, and legend elements are separate PowerPoint objects. Imported custom SVG pins remain separate movable vector objects.</a:t>
+Layer 1: Layer #1 - US ITER cities (visible)
+Layer 2: Layer #2 - IO cities (visible)
+Editability: states, boundaries, text, standard pins, and legend elements are separate PowerPoint objects. Visible location objects are prefixed with their layer name in PowerPoint's Selection Pane. Imported custom SVG pins remain separate movable vector objects.</a:t>
             </a:r>
             <a:endParaRPr lang="en-US" dirty="0"/>
           </a:p>
@@ -977,7 +979,7 @@
                 <a:ea typeface="Aptos" pitchFamily="34" charset="-122"/>
                 <a:cs typeface="Aptos" pitchFamily="34" charset="-120"/>
               </a:rPr>
-              <a:t>Every state, label, pin, and legend element can be selected independently</a:t>
+              <a:t>Editable objects with layer-prefixed Selection Pane names</a:t>
             </a:r>
             <a:endParaRPr lang="en-US" sz="975" dirty="0"/>
           </a:p>
@@ -31361,16 +31363,16 @@
       </p:sp>
       <p:sp>
         <p:nvSpPr>
-          <p:cNvPr id="108" name="Pin - Seattle, WA"/>
+          <p:cNvPr id="108" name="[Layer 1: Layer #1 - US ITER cities] Pin - Seattle, WA"/>
           <p:cNvSpPr/>
           <p:nvPr/>
         </p:nvSpPr>
         <p:spPr>
-          <a:xfrm rot="2700000">
-            <a:off x="2804234" y="1188522"/>
-            <a:ext cx="114300" cy="152400"/>
+          <a:xfrm>
+            <a:off x="2788232" y="1223574"/>
+            <a:ext cx="146304" cy="146304"/>
           </a:xfrm>
-          <a:prstGeom prst="teardrop">
+          <a:prstGeom prst="ellipse">
             <a:avLst/>
           </a:prstGeom>
           <a:solidFill>
@@ -31386,34 +31388,7 @@
       </p:sp>
       <p:sp>
         <p:nvSpPr>
-          <p:cNvPr id="109" name="Pin center - Seattle, WA"/>
-          <p:cNvSpPr/>
-          <p:nvPr/>
-        </p:nvSpPr>
-        <p:spPr>
-          <a:xfrm>
-            <a:off x="2843858" y="1228146"/>
-            <a:ext cx="35052" cy="35052"/>
-          </a:xfrm>
-          <a:prstGeom prst="ellipse">
-            <a:avLst/>
-          </a:prstGeom>
-          <a:solidFill>
-            <a:srgbClr val="FFFFFF"/>
-          </a:solidFill>
-          <a:ln w="12700">
-            <a:solidFill>
-              <a:srgbClr val="FFFFFF">
-                <a:alpha val="0"/>
-              </a:srgbClr>
-            </a:solidFill>
-            <a:prstDash val="solid"/>
-          </a:ln>
-        </p:spPr>
-      </p:sp>
-      <p:sp>
-        <p:nvSpPr>
-          <p:cNvPr id="110" name="Location label - Seattle, WA"/>
+          <p:cNvPr id="109" name="[Layer 1: Layer #1 - US ITER cities] Location label - Seattle, WA"/>
           <p:cNvSpPr/>
           <p:nvPr/>
         </p:nvSpPr>
@@ -31437,11 +31412,6 @@
             </a:pPr>
             <a:r>
               <a:rPr lang="en-US" sz="860" b="1" dirty="0">
-                <a:ln w="25400">
-                  <a:solidFill>
-                    <a:srgbClr val="FFFFFF"/>
-                  </a:solidFill>
-                </a:ln>
                 <a:solidFill>
                   <a:srgbClr val="373A36"/>
                 </a:solidFill>
@@ -31457,20 +31427,20 @@
       </p:sp>
       <p:sp>
         <p:nvSpPr>
-          <p:cNvPr id="111" name="Pin - San Francisco, CA"/>
+          <p:cNvPr id="110" name="[Layer 1: Layer #1 - US ITER cities] Pin - San Francisco, CA"/>
           <p:cNvSpPr/>
           <p:nvPr/>
         </p:nvSpPr>
         <p:spPr>
-          <a:xfrm rot="2700000">
-            <a:off x="2227795" y="3163577"/>
-            <a:ext cx="114300" cy="152400"/>
+          <a:xfrm>
+            <a:off x="2211793" y="3198629"/>
+            <a:ext cx="146304" cy="146304"/>
           </a:xfrm>
-          <a:prstGeom prst="teardrop">
+          <a:prstGeom prst="ellipse">
             <a:avLst/>
           </a:prstGeom>
           <a:solidFill>
-            <a:srgbClr val="00B38F"/>
+            <a:srgbClr val="00662C"/>
           </a:solidFill>
           <a:ln w="19812">
             <a:solidFill>
@@ -31482,34 +31452,7 @@
       </p:sp>
       <p:sp>
         <p:nvSpPr>
-          <p:cNvPr id="112" name="Pin center - San Francisco, CA"/>
-          <p:cNvSpPr/>
-          <p:nvPr/>
-        </p:nvSpPr>
-        <p:spPr>
-          <a:xfrm>
-            <a:off x="2267419" y="3203201"/>
-            <a:ext cx="35052" cy="35052"/>
-          </a:xfrm>
-          <a:prstGeom prst="ellipse">
-            <a:avLst/>
-          </a:prstGeom>
-          <a:solidFill>
-            <a:srgbClr val="FFFFFF"/>
-          </a:solidFill>
-          <a:ln w="12700">
-            <a:solidFill>
-              <a:srgbClr val="FFFFFF">
-                <a:alpha val="0"/>
-              </a:srgbClr>
-            </a:solidFill>
-            <a:prstDash val="solid"/>
-          </a:ln>
-        </p:spPr>
-      </p:sp>
-      <p:sp>
-        <p:nvSpPr>
-          <p:cNvPr id="113" name="Location label - San Francisco, CA"/>
+          <p:cNvPr id="111" name="[Layer 1: Layer #1 - US ITER cities] Location label - San Francisco, CA"/>
           <p:cNvSpPr/>
           <p:nvPr/>
         </p:nvSpPr>
@@ -31533,11 +31476,6 @@
             </a:pPr>
             <a:r>
               <a:rPr lang="en-US" sz="860" b="1" dirty="0">
-                <a:ln w="25400">
-                  <a:solidFill>
-                    <a:srgbClr val="FFFFFF"/>
-                  </a:solidFill>
-                </a:ln>
                 <a:solidFill>
                   <a:srgbClr val="373A36"/>
                 </a:solidFill>
@@ -31553,20 +31491,20 @@
       </p:sp>
       <p:sp>
         <p:nvSpPr>
-          <p:cNvPr id="114" name="Pin - Denver, CO"/>
+          <p:cNvPr id="112" name="[Layer 1: Layer #1 - US ITER cities] Pin - Denver, CO"/>
           <p:cNvSpPr/>
           <p:nvPr/>
         </p:nvSpPr>
         <p:spPr>
-          <a:xfrm rot="2700000">
-            <a:off x="5055679" y="3277876"/>
-            <a:ext cx="114300" cy="152400"/>
+          <a:xfrm>
+            <a:off x="5039677" y="3312928"/>
+            <a:ext cx="146304" cy="146304"/>
           </a:xfrm>
-          <a:prstGeom prst="teardrop">
+          <a:prstGeom prst="ellipse">
             <a:avLst/>
           </a:prstGeom>
           <a:solidFill>
-            <a:srgbClr val="006BA6"/>
+            <a:srgbClr val="00662C"/>
           </a:solidFill>
           <a:ln w="19812">
             <a:solidFill>
@@ -31578,34 +31516,7 @@
       </p:sp>
       <p:sp>
         <p:nvSpPr>
-          <p:cNvPr id="115" name="Pin center - Denver, CO"/>
-          <p:cNvSpPr/>
-          <p:nvPr/>
-        </p:nvSpPr>
-        <p:spPr>
-          <a:xfrm>
-            <a:off x="5095303" y="3317500"/>
-            <a:ext cx="35052" cy="35052"/>
-          </a:xfrm>
-          <a:prstGeom prst="ellipse">
-            <a:avLst/>
-          </a:prstGeom>
-          <a:solidFill>
-            <a:srgbClr val="FFFFFF"/>
-          </a:solidFill>
-          <a:ln w="12700">
-            <a:solidFill>
-              <a:srgbClr val="FFFFFF">
-                <a:alpha val="0"/>
-              </a:srgbClr>
-            </a:solidFill>
-            <a:prstDash val="solid"/>
-          </a:ln>
-        </p:spPr>
-      </p:sp>
-      <p:sp>
-        <p:nvSpPr>
-          <p:cNvPr id="116" name="Location label - Denver, CO"/>
+          <p:cNvPr id="113" name="[Layer 1: Layer #1 - US ITER cities] Location label - Denver, CO"/>
           <p:cNvSpPr/>
           <p:nvPr/>
         </p:nvSpPr>
@@ -31629,11 +31540,6 @@
             </a:pPr>
             <a:r>
               <a:rPr lang="en-US" sz="860" b="1" dirty="0">
-                <a:ln w="25400">
-                  <a:solidFill>
-                    <a:srgbClr val="FFFFFF"/>
-                  </a:solidFill>
-                </a:ln>
                 <a:solidFill>
                   <a:srgbClr val="373A36"/>
                 </a:solidFill>
@@ -31649,20 +31555,20 @@
       </p:sp>
       <p:sp>
         <p:nvSpPr>
-          <p:cNvPr id="117" name="Pin - Oak Ridge, TN"/>
+          <p:cNvPr id="114" name="[Layer 1: Layer #1 - US ITER cities] Pin - Oak Ridge, TN"/>
           <p:cNvSpPr/>
           <p:nvPr/>
         </p:nvSpPr>
         <p:spPr>
-          <a:xfrm rot="2700000">
-            <a:off x="8433963" y="4008870"/>
-            <a:ext cx="114300" cy="152400"/>
+          <a:xfrm>
+            <a:off x="8417961" y="4043922"/>
+            <a:ext cx="146304" cy="146304"/>
           </a:xfrm>
-          <a:prstGeom prst="teardrop">
+          <a:prstGeom prst="ellipse">
             <a:avLst/>
           </a:prstGeom>
           <a:solidFill>
-            <a:srgbClr val="FE5000"/>
+            <a:srgbClr val="00662C"/>
           </a:solidFill>
           <a:ln w="19812">
             <a:solidFill>
@@ -31674,34 +31580,7 @@
       </p:sp>
       <p:sp>
         <p:nvSpPr>
-          <p:cNvPr id="118" name="Pin center - Oak Ridge, TN"/>
-          <p:cNvSpPr/>
-          <p:nvPr/>
-        </p:nvSpPr>
-        <p:spPr>
-          <a:xfrm>
-            <a:off x="8473587" y="4048494"/>
-            <a:ext cx="35052" cy="35052"/>
-          </a:xfrm>
-          <a:prstGeom prst="ellipse">
-            <a:avLst/>
-          </a:prstGeom>
-          <a:solidFill>
-            <a:srgbClr val="FFFFFF"/>
-          </a:solidFill>
-          <a:ln w="12700">
-            <a:solidFill>
-              <a:srgbClr val="FFFFFF">
-                <a:alpha val="0"/>
-              </a:srgbClr>
-            </a:solidFill>
-            <a:prstDash val="solid"/>
-          </a:ln>
-        </p:spPr>
-      </p:sp>
-      <p:sp>
-        <p:nvSpPr>
-          <p:cNvPr id="119" name="Location label - Oak Ridge, TN"/>
+          <p:cNvPr id="115" name="[Layer 1: Layer #1 - US ITER cities] Location label - Oak Ridge, TN"/>
           <p:cNvSpPr/>
           <p:nvPr/>
         </p:nvSpPr>
@@ -31725,11 +31604,6 @@
             </a:pPr>
             <a:r>
               <a:rPr lang="en-US" sz="860" b="1" dirty="0">
-                <a:ln w="25400">
-                  <a:solidFill>
-                    <a:srgbClr val="FFFFFF"/>
-                  </a:solidFill>
-                </a:ln>
                 <a:solidFill>
                   <a:srgbClr val="373A36"/>
                 </a:solidFill>
@@ -31745,20 +31619,20 @@
       </p:sp>
       <p:sp>
         <p:nvSpPr>
-          <p:cNvPr id="120" name="Pin - Chicago, IL"/>
+          <p:cNvPr id="116" name="[Layer 2: Layer #2 - IO cities] Pin - Chicago, IL"/>
           <p:cNvSpPr/>
           <p:nvPr/>
         </p:nvSpPr>
         <p:spPr>
-          <a:xfrm rot="2700000">
-            <a:off x="7767602" y="2839263"/>
-            <a:ext cx="114300" cy="152400"/>
+          <a:xfrm>
+            <a:off x="7751600" y="2874315"/>
+            <a:ext cx="146304" cy="146304"/>
           </a:xfrm>
-          <a:prstGeom prst="teardrop">
+          <a:prstGeom prst="ellipse">
             <a:avLst/>
           </a:prstGeom>
           <a:solidFill>
-            <a:srgbClr val="00454D"/>
+            <a:srgbClr val="00662C"/>
           </a:solidFill>
           <a:ln w="19812">
             <a:solidFill>
@@ -31770,34 +31644,7 @@
       </p:sp>
       <p:sp>
         <p:nvSpPr>
-          <p:cNvPr id="121" name="Pin center - Chicago, IL"/>
-          <p:cNvSpPr/>
-          <p:nvPr/>
-        </p:nvSpPr>
-        <p:spPr>
-          <a:xfrm>
-            <a:off x="7807226" y="2878887"/>
-            <a:ext cx="35052" cy="35052"/>
-          </a:xfrm>
-          <a:prstGeom prst="ellipse">
-            <a:avLst/>
-          </a:prstGeom>
-          <a:solidFill>
-            <a:srgbClr val="FFFFFF"/>
-          </a:solidFill>
-          <a:ln w="12700">
-            <a:solidFill>
-              <a:srgbClr val="FFFFFF">
-                <a:alpha val="0"/>
-              </a:srgbClr>
-            </a:solidFill>
-            <a:prstDash val="solid"/>
-          </a:ln>
-        </p:spPr>
-      </p:sp>
-      <p:sp>
-        <p:nvSpPr>
-          <p:cNvPr id="122" name="Location label - Chicago, IL"/>
+          <p:cNvPr id="117" name="[Layer 2: Layer #2 - IO cities] Location label - Chicago, IL"/>
           <p:cNvSpPr/>
           <p:nvPr/>
         </p:nvSpPr>
@@ -31821,11 +31668,6 @@
             </a:pPr>
             <a:r>
               <a:rPr lang="en-US" sz="860" b="1" dirty="0">
-                <a:ln w="25400">
-                  <a:solidFill>
-                    <a:srgbClr val="FFFFFF"/>
-                  </a:solidFill>
-                </a:ln>
                 <a:solidFill>
                   <a:srgbClr val="373A36"/>
                 </a:solidFill>
@@ -31841,20 +31683,20 @@
       </p:sp>
       <p:sp>
         <p:nvSpPr>
-          <p:cNvPr id="123" name="Pin - Atlanta, GA"/>
+          <p:cNvPr id="118" name="[Layer 2: Layer #2 - IO cities] Pin - Atlanta, GA"/>
           <p:cNvSpPr/>
           <p:nvPr/>
         </p:nvSpPr>
         <p:spPr>
-          <a:xfrm rot="2700000">
-            <a:off x="8472238" y="4482792"/>
-            <a:ext cx="114300" cy="152400"/>
+          <a:xfrm>
+            <a:off x="8456236" y="4517844"/>
+            <a:ext cx="146304" cy="146304"/>
           </a:xfrm>
-          <a:prstGeom prst="teardrop">
+          <a:prstGeom prst="ellipse">
             <a:avLst/>
           </a:prstGeom>
           <a:solidFill>
-            <a:srgbClr val="7DBA00"/>
+            <a:srgbClr val="00662C"/>
           </a:solidFill>
           <a:ln w="19812">
             <a:solidFill>
@@ -31866,34 +31708,7 @@
       </p:sp>
       <p:sp>
         <p:nvSpPr>
-          <p:cNvPr id="124" name="Pin center - Atlanta, GA"/>
-          <p:cNvSpPr/>
-          <p:nvPr/>
-        </p:nvSpPr>
-        <p:spPr>
-          <a:xfrm>
-            <a:off x="8511862" y="4522416"/>
-            <a:ext cx="35052" cy="35052"/>
-          </a:xfrm>
-          <a:prstGeom prst="ellipse">
-            <a:avLst/>
-          </a:prstGeom>
-          <a:solidFill>
-            <a:srgbClr val="FFFFFF"/>
-          </a:solidFill>
-          <a:ln w="12700">
-            <a:solidFill>
-              <a:srgbClr val="FFFFFF">
-                <a:alpha val="0"/>
-              </a:srgbClr>
-            </a:solidFill>
-            <a:prstDash val="solid"/>
-          </a:ln>
-        </p:spPr>
-      </p:sp>
-      <p:sp>
-        <p:nvSpPr>
-          <p:cNvPr id="125" name="Location label - Atlanta, GA"/>
+          <p:cNvPr id="119" name="[Layer 2: Layer #2 - IO cities] Location label - Atlanta, GA"/>
           <p:cNvSpPr/>
           <p:nvPr/>
         </p:nvSpPr>
@@ -31917,11 +31732,6 @@
             </a:pPr>
             <a:r>
               <a:rPr lang="en-US" sz="860" b="1" dirty="0">
-                <a:ln w="25400">
-                  <a:solidFill>
-                    <a:srgbClr val="FFFFFF"/>
-                  </a:solidFill>
-                </a:ln>
                 <a:solidFill>
                   <a:srgbClr val="373A36"/>
                 </a:solidFill>
@@ -31937,20 +31747,20 @@
       </p:sp>
       <p:sp>
         <p:nvSpPr>
-          <p:cNvPr id="126" name="Pin - Washington, DC"/>
+          <p:cNvPr id="120" name="[Layer 2: Layer #2 - IO cities] Pin - Washington, DC"/>
           <p:cNvSpPr/>
           <p:nvPr/>
         </p:nvSpPr>
         <p:spPr>
-          <a:xfrm rot="2700000">
-            <a:off x="9504789" y="3217561"/>
-            <a:ext cx="114300" cy="152400"/>
+          <a:xfrm>
+            <a:off x="9488787" y="3252613"/>
+            <a:ext cx="146304" cy="146304"/>
           </a:xfrm>
-          <a:prstGeom prst="teardrop">
+          <a:prstGeom prst="ellipse">
             <a:avLst/>
           </a:prstGeom>
           <a:solidFill>
-            <a:srgbClr val="B50094"/>
+            <a:srgbClr val="00662C"/>
           </a:solidFill>
           <a:ln w="19812">
             <a:solidFill>
@@ -31962,34 +31772,7 @@
       </p:sp>
       <p:sp>
         <p:nvSpPr>
-          <p:cNvPr id="127" name="Pin center - Washington, DC"/>
-          <p:cNvSpPr/>
-          <p:nvPr/>
-        </p:nvSpPr>
-        <p:spPr>
-          <a:xfrm>
-            <a:off x="9544413" y="3257185"/>
-            <a:ext cx="35052" cy="35052"/>
-          </a:xfrm>
-          <a:prstGeom prst="ellipse">
-            <a:avLst/>
-          </a:prstGeom>
-          <a:solidFill>
-            <a:srgbClr val="FFFFFF"/>
-          </a:solidFill>
-          <a:ln w="12700">
-            <a:solidFill>
-              <a:srgbClr val="FFFFFF">
-                <a:alpha val="0"/>
-              </a:srgbClr>
-            </a:solidFill>
-            <a:prstDash val="solid"/>
-          </a:ln>
-        </p:spPr>
-      </p:sp>
-      <p:sp>
-        <p:nvSpPr>
-          <p:cNvPr id="128" name="Location label - Washington, DC"/>
+          <p:cNvPr id="121" name="[Layer 2: Layer #2 - IO cities] Location label - Washington, DC"/>
           <p:cNvSpPr/>
           <p:nvPr/>
         </p:nvSpPr>
@@ -32013,11 +31796,6 @@
             </a:pPr>
             <a:r>
               <a:rPr lang="en-US" sz="860" b="1" dirty="0">
-                <a:ln w="25400">
-                  <a:solidFill>
-                    <a:srgbClr val="FFFFFF"/>
-                  </a:solidFill>
-                </a:ln>
                 <a:solidFill>
                   <a:srgbClr val="373A36"/>
                 </a:solidFill>
@@ -32033,20 +31811,20 @@
       </p:sp>
       <p:sp>
         <p:nvSpPr>
-          <p:cNvPr id="129" name="Pin - New York, NY"/>
+          <p:cNvPr id="122" name="[Layer 2: Layer #2 - IO cities] Pin - New York, NY"/>
           <p:cNvSpPr/>
           <p:nvPr/>
         </p:nvSpPr>
         <p:spPr>
-          <a:xfrm rot="2700000">
-            <a:off x="9893068" y="2744037"/>
-            <a:ext cx="114300" cy="152400"/>
+          <a:xfrm>
+            <a:off x="9877066" y="2779089"/>
+            <a:ext cx="146304" cy="146304"/>
           </a:xfrm>
-          <a:prstGeom prst="teardrop">
+          <a:prstGeom prst="ellipse">
             <a:avLst/>
           </a:prstGeom>
           <a:solidFill>
-            <a:srgbClr val="4E008E"/>
+            <a:srgbClr val="00662C"/>
           </a:solidFill>
           <a:ln w="19812">
             <a:solidFill>
@@ -32058,34 +31836,7 @@
       </p:sp>
       <p:sp>
         <p:nvSpPr>
-          <p:cNvPr id="130" name="Pin center - New York, NY"/>
-          <p:cNvSpPr/>
-          <p:nvPr/>
-        </p:nvSpPr>
-        <p:spPr>
-          <a:xfrm>
-            <a:off x="9932692" y="2783661"/>
-            <a:ext cx="35052" cy="35052"/>
-          </a:xfrm>
-          <a:prstGeom prst="ellipse">
-            <a:avLst/>
-          </a:prstGeom>
-          <a:solidFill>
-            <a:srgbClr val="FFFFFF"/>
-          </a:solidFill>
-          <a:ln w="12700">
-            <a:solidFill>
-              <a:srgbClr val="FFFFFF">
-                <a:alpha val="0"/>
-              </a:srgbClr>
-            </a:solidFill>
-            <a:prstDash val="solid"/>
-          </a:ln>
-        </p:spPr>
-      </p:sp>
-      <p:sp>
-        <p:nvSpPr>
-          <p:cNvPr id="131" name="Location label - New York, NY"/>
+          <p:cNvPr id="123" name="[Layer 2: Layer #2 - IO cities] Location label - New York, NY"/>
           <p:cNvSpPr/>
           <p:nvPr/>
         </p:nvSpPr>
@@ -32109,11 +31860,6 @@
             </a:pPr>
             <a:r>
               <a:rPr lang="en-US" sz="860" b="1" dirty="0">
-                <a:ln w="25400">
-                  <a:solidFill>
-                    <a:srgbClr val="FFFFFF"/>
-                  </a:solidFill>
-                </a:ln>
                 <a:solidFill>
                   <a:srgbClr val="373A36"/>
                 </a:solidFill>
@@ -32129,7 +31875,7 @@
       </p:sp>
       <p:sp>
         <p:nvSpPr>
-          <p:cNvPr id="132" name="Legend background"/>
+          <p:cNvPr id="124" name="Legend background"/>
           <p:cNvSpPr/>
           <p:nvPr/>
         </p:nvSpPr>
@@ -32154,7 +31900,7 @@
       </p:sp>
       <p:sp>
         <p:nvSpPr>
-          <p:cNvPr id="133" name="Legend location symbol"/>
+          <p:cNvPr id="125" name="Legend location symbol"/>
           <p:cNvSpPr/>
           <p:nvPr/>
         </p:nvSpPr>
@@ -32181,7 +31927,7 @@
       </p:sp>
       <p:sp>
         <p:nvSpPr>
-          <p:cNvPr id="134" name="Legend location count"/>
+          <p:cNvPr id="126" name="Legend location count"/>
           <p:cNvSpPr/>
           <p:nvPr/>
         </p:nvSpPr>
@@ -32212,7 +31958,7 @@
                 <a:ea typeface="Aptos" pitchFamily="34" charset="-122"/>
                 <a:cs typeface="Aptos" pitchFamily="34" charset="-120"/>
               </a:rPr>
-              <a:t>8 mapped locations</a:t>
+              <a:t>8 visible locations</a:t>
             </a:r>
             <a:endParaRPr lang="en-US" sz="710" dirty="0"/>
           </a:p>
@@ -32220,7 +31966,7 @@
       </p:sp>
       <p:sp>
         <p:nvSpPr>
-          <p:cNvPr id="135" name="Legend boundary symbol"/>
+          <p:cNvPr id="127" name="Legend boundary symbol"/>
           <p:cNvSpPr/>
           <p:nvPr/>
         </p:nvSpPr>
@@ -32243,7 +31989,7 @@
       </p:sp>
       <p:sp>
         <p:nvSpPr>
-          <p:cNvPr id="136" name="Legend geography source"/>
+          <p:cNvPr id="128" name="Legend geography source"/>
           <p:cNvSpPr/>
           <p:nvPr/>
         </p:nvSpPr>

</xml_diff>

<commit_message>
Add editable multi-label map callouts
</commit_message>
<xml_diff>
--- a/examples/usa-map-studio-editable-export.pptx
+++ b/examples/usa-map-studio-editable-export.pptx
@@ -979,7 +979,7 @@
                 <a:ea typeface="Aptos" pitchFamily="34" charset="-122"/>
                 <a:cs typeface="Aptos" pitchFamily="34" charset="-120"/>
               </a:rPr>
-              <a:t>Editable objects with layer-prefixed Selection Pane names</a:t>
+              <a:t>Editable City and Company labels, leader lines, pins, and layer-prefixed Selection Pane names</a:t>
             </a:r>
             <a:endParaRPr lang="en-US" sz="975" dirty="0"/>
           </a:p>
@@ -31388,14 +31388,14 @@
       </p:sp>
       <p:sp>
         <p:nvSpPr>
-          <p:cNvPr id="109" name="[Layer 1: Layer #1 - US ITER cities] Location label - Seattle, WA"/>
+          <p:cNvPr id="109" name="[Layer 1: Layer #1 - US ITER cities] City label - Seattle, WA"/>
           <p:cNvSpPr/>
           <p:nvPr/>
         </p:nvSpPr>
         <p:spPr>
           <a:xfrm>
-            <a:off x="3032834" y="1243386"/>
-            <a:ext cx="754380" cy="182880"/>
+            <a:off x="3040454" y="1170472"/>
+            <a:ext cx="666772" cy="133636"/>
           </a:xfrm>
           <a:prstGeom prst="rect">
             <a:avLst/>
@@ -31404,14 +31404,14 @@
           <a:ln/>
         </p:spPr>
         <p:txBody>
-          <a:bodyPr wrap="square" lIns="0" tIns="0" rIns="0" bIns="0" rtlCol="0" anchor="ctr"/>
+          <a:bodyPr wrap="square" lIns="0" tIns="0" rIns="0" bIns="0" rtlCol="0" anchor="t"/>
           <a:lstStyle/>
           <a:p>
             <a:pPr algn="l" indent="0" marL="0">
               <a:buNone/>
             </a:pPr>
             <a:r>
-              <a:rPr lang="en-US" sz="860" b="1" dirty="0">
+              <a:rPr lang="en-US" sz="863" b="1" dirty="0">
                 <a:solidFill>
                   <a:srgbClr val="373A36"/>
                 </a:solidFill>
@@ -31421,13 +31421,52 @@
               </a:rPr>
               <a:t>Seattle, WA</a:t>
             </a:r>
-            <a:endParaRPr lang="en-US" sz="860" dirty="0"/>
+            <a:endParaRPr lang="en-US" sz="863" dirty="0"/>
           </a:p>
         </p:txBody>
       </p:sp>
       <p:sp>
         <p:nvSpPr>
-          <p:cNvPr id="110" name="[Layer 1: Layer #1 - US ITER cities] Pin - San Francisco, CA"/>
+          <p:cNvPr id="110" name="[Layer 1: Layer #1 - US ITER cities] Company label - Example partner 1"/>
+          <p:cNvSpPr/>
+          <p:nvPr/>
+        </p:nvSpPr>
+        <p:spPr>
+          <a:xfrm>
+            <a:off x="3040454" y="1318395"/>
+            <a:ext cx="752094" cy="104585"/>
+          </a:xfrm>
+          <a:prstGeom prst="rect">
+            <a:avLst/>
+          </a:prstGeom>
+          <a:noFill/>
+          <a:ln/>
+        </p:spPr>
+        <p:txBody>
+          <a:bodyPr wrap="square" lIns="0" tIns="0" rIns="0" bIns="0" rtlCol="0" anchor="t"/>
+          <a:lstStyle/>
+          <a:p>
+            <a:pPr algn="l" indent="0" marL="0">
+              <a:buNone/>
+            </a:pPr>
+            <a:r>
+              <a:rPr lang="en-US" sz="675" b="1" dirty="0">
+                <a:solidFill>
+                  <a:srgbClr val="00454D"/>
+                </a:solidFill>
+                <a:latin typeface="Arial" pitchFamily="34" charset="0"/>
+                <a:ea typeface="Arial" pitchFamily="34" charset="-122"/>
+                <a:cs typeface="Arial" pitchFamily="34" charset="-120"/>
+              </a:rPr>
+              <a:t>Example partner 1</a:t>
+            </a:r>
+            <a:endParaRPr lang="en-US" sz="675" dirty="0"/>
+          </a:p>
+        </p:txBody>
+      </p:sp>
+      <p:sp>
+        <p:nvSpPr>
+          <p:cNvPr id="111" name="[Layer 1: Layer #1 - US ITER cities] Pin - San Francisco, CA"/>
           <p:cNvSpPr/>
           <p:nvPr/>
         </p:nvSpPr>
@@ -31452,14 +31491,14 @@
       </p:sp>
       <p:sp>
         <p:nvSpPr>
-          <p:cNvPr id="111" name="[Layer 1: Layer #1 - US ITER cities] Location label - San Francisco, CA"/>
+          <p:cNvPr id="112" name="[Layer 1: Layer #1 - US ITER cities] City label - San Francisco, CA"/>
           <p:cNvSpPr/>
           <p:nvPr/>
         </p:nvSpPr>
         <p:spPr>
           <a:xfrm>
-            <a:off x="2456395" y="3218441"/>
-            <a:ext cx="1165860" cy="182880"/>
+            <a:off x="2464015" y="3145527"/>
+            <a:ext cx="988746" cy="133636"/>
           </a:xfrm>
           <a:prstGeom prst="rect">
             <a:avLst/>
@@ -31468,14 +31507,14 @@
           <a:ln/>
         </p:spPr>
         <p:txBody>
-          <a:bodyPr wrap="square" lIns="0" tIns="0" rIns="0" bIns="0" rtlCol="0" anchor="ctr"/>
+          <a:bodyPr wrap="square" lIns="0" tIns="0" rIns="0" bIns="0" rtlCol="0" anchor="t"/>
           <a:lstStyle/>
           <a:p>
             <a:pPr algn="l" indent="0" marL="0">
               <a:buNone/>
             </a:pPr>
             <a:r>
-              <a:rPr lang="en-US" sz="860" b="1" dirty="0">
+              <a:rPr lang="en-US" sz="863" b="1" dirty="0">
                 <a:solidFill>
                   <a:srgbClr val="373A36"/>
                 </a:solidFill>
@@ -31485,13 +31524,52 @@
               </a:rPr>
               <a:t>San Francisco, CA</a:t>
             </a:r>
-            <a:endParaRPr lang="en-US" sz="860" dirty="0"/>
+            <a:endParaRPr lang="en-US" sz="863" dirty="0"/>
           </a:p>
         </p:txBody>
       </p:sp>
       <p:sp>
         <p:nvSpPr>
-          <p:cNvPr id="112" name="[Layer 1: Layer #1 - US ITER cities] Pin - Denver, CO"/>
+          <p:cNvPr id="113" name="[Layer 1: Layer #1 - US ITER cities] Company label - Example partner 2"/>
+          <p:cNvSpPr/>
+          <p:nvPr/>
+        </p:nvSpPr>
+        <p:spPr>
+          <a:xfrm>
+            <a:off x="2464015" y="3293451"/>
+            <a:ext cx="770954" cy="104585"/>
+          </a:xfrm>
+          <a:prstGeom prst="rect">
+            <a:avLst/>
+          </a:prstGeom>
+          <a:noFill/>
+          <a:ln/>
+        </p:spPr>
+        <p:txBody>
+          <a:bodyPr wrap="square" lIns="0" tIns="0" rIns="0" bIns="0" rtlCol="0" anchor="t"/>
+          <a:lstStyle/>
+          <a:p>
+            <a:pPr algn="l" indent="0" marL="0">
+              <a:buNone/>
+            </a:pPr>
+            <a:r>
+              <a:rPr lang="en-US" sz="675" b="1" dirty="0">
+                <a:solidFill>
+                  <a:srgbClr val="00454D"/>
+                </a:solidFill>
+                <a:latin typeface="Arial" pitchFamily="34" charset="0"/>
+                <a:ea typeface="Arial" pitchFamily="34" charset="-122"/>
+                <a:cs typeface="Arial" pitchFamily="34" charset="-120"/>
+              </a:rPr>
+              <a:t>Example partner 2</a:t>
+            </a:r>
+            <a:endParaRPr lang="en-US" sz="675" dirty="0"/>
+          </a:p>
+        </p:txBody>
+      </p:sp>
+      <p:sp>
+        <p:nvSpPr>
+          <p:cNvPr id="114" name="[Layer 1: Layer #1 - US ITER cities] Pin - Denver, CO"/>
           <p:cNvSpPr/>
           <p:nvPr/>
         </p:nvSpPr>
@@ -31516,14 +31594,14 @@
       </p:sp>
       <p:sp>
         <p:nvSpPr>
-          <p:cNvPr id="113" name="[Layer 1: Layer #1 - US ITER cities] Location label - Denver, CO"/>
+          <p:cNvPr id="115" name="[Layer 1: Layer #1 - US ITER cities] City label - Denver, CO"/>
           <p:cNvSpPr/>
           <p:nvPr/>
         </p:nvSpPr>
         <p:spPr>
           <a:xfrm>
-            <a:off x="5284279" y="3332740"/>
-            <a:ext cx="685800" cy="182880"/>
+            <a:off x="5291899" y="3259826"/>
+            <a:ext cx="628226" cy="133636"/>
           </a:xfrm>
           <a:prstGeom prst="rect">
             <a:avLst/>
@@ -31532,14 +31610,14 @@
           <a:ln/>
         </p:spPr>
         <p:txBody>
-          <a:bodyPr wrap="square" lIns="0" tIns="0" rIns="0" bIns="0" rtlCol="0" anchor="ctr"/>
+          <a:bodyPr wrap="square" lIns="0" tIns="0" rIns="0" bIns="0" rtlCol="0" anchor="t"/>
           <a:lstStyle/>
           <a:p>
             <a:pPr algn="l" indent="0" marL="0">
               <a:buNone/>
             </a:pPr>
             <a:r>
-              <a:rPr lang="en-US" sz="860" b="1" dirty="0">
+              <a:rPr lang="en-US" sz="863" b="1" dirty="0">
                 <a:solidFill>
                   <a:srgbClr val="373A36"/>
                 </a:solidFill>
@@ -31549,13 +31627,52 @@
               </a:rPr>
               <a:t>Denver, CO</a:t>
             </a:r>
-            <a:endParaRPr lang="en-US" sz="860" dirty="0"/>
+            <a:endParaRPr lang="en-US" sz="863" dirty="0"/>
           </a:p>
         </p:txBody>
       </p:sp>
       <p:sp>
         <p:nvSpPr>
-          <p:cNvPr id="114" name="[Layer 1: Layer #1 - US ITER cities] Pin - Oak Ridge, TN"/>
+          <p:cNvPr id="116" name="[Layer 1: Layer #1 - US ITER cities] Company label - Example partner 3"/>
+          <p:cNvSpPr/>
+          <p:nvPr/>
+        </p:nvSpPr>
+        <p:spPr>
+          <a:xfrm>
+            <a:off x="5291899" y="3407749"/>
+            <a:ext cx="770954" cy="104585"/>
+          </a:xfrm>
+          <a:prstGeom prst="rect">
+            <a:avLst/>
+          </a:prstGeom>
+          <a:noFill/>
+          <a:ln/>
+        </p:spPr>
+        <p:txBody>
+          <a:bodyPr wrap="square" lIns="0" tIns="0" rIns="0" bIns="0" rtlCol="0" anchor="t"/>
+          <a:lstStyle/>
+          <a:p>
+            <a:pPr algn="l" indent="0" marL="0">
+              <a:buNone/>
+            </a:pPr>
+            <a:r>
+              <a:rPr lang="en-US" sz="675" b="1" dirty="0">
+                <a:solidFill>
+                  <a:srgbClr val="00454D"/>
+                </a:solidFill>
+                <a:latin typeface="Arial" pitchFamily="34" charset="0"/>
+                <a:ea typeface="Arial" pitchFamily="34" charset="-122"/>
+                <a:cs typeface="Arial" pitchFamily="34" charset="-120"/>
+              </a:rPr>
+              <a:t>Example partner 3</a:t>
+            </a:r>
+            <a:endParaRPr lang="en-US" sz="675" dirty="0"/>
+          </a:p>
+        </p:txBody>
+      </p:sp>
+      <p:sp>
+        <p:nvSpPr>
+          <p:cNvPr id="117" name="[Layer 1: Layer #1 - US ITER cities] Pin - Oak Ridge, TN"/>
           <p:cNvSpPr/>
           <p:nvPr/>
         </p:nvSpPr>
@@ -31580,14 +31697,14 @@
       </p:sp>
       <p:sp>
         <p:nvSpPr>
-          <p:cNvPr id="115" name="[Layer 1: Layer #1 - US ITER cities] Location label - Oak Ridge, TN"/>
+          <p:cNvPr id="118" name="[Layer 1: Layer #1 - US ITER cities] City label - Oak Ridge, TN"/>
           <p:cNvSpPr/>
           <p:nvPr/>
         </p:nvSpPr>
         <p:spPr>
           <a:xfrm>
-            <a:off x="8662563" y="4063734"/>
-            <a:ext cx="891540" cy="182880"/>
+            <a:off x="8670183" y="3990820"/>
+            <a:ext cx="764271" cy="133636"/>
           </a:xfrm>
           <a:prstGeom prst="rect">
             <a:avLst/>
@@ -31596,14 +31713,14 @@
           <a:ln/>
         </p:spPr>
         <p:txBody>
-          <a:bodyPr wrap="square" lIns="0" tIns="0" rIns="0" bIns="0" rtlCol="0" anchor="ctr"/>
+          <a:bodyPr wrap="square" lIns="0" tIns="0" rIns="0" bIns="0" rtlCol="0" anchor="t"/>
           <a:lstStyle/>
           <a:p>
             <a:pPr algn="l" indent="0" marL="0">
               <a:buNone/>
             </a:pPr>
             <a:r>
-              <a:rPr lang="en-US" sz="860" b="1" dirty="0">
+              <a:rPr lang="en-US" sz="863" b="1" dirty="0">
                 <a:solidFill>
                   <a:srgbClr val="373A36"/>
                 </a:solidFill>
@@ -31613,13 +31730,52 @@
               </a:rPr>
               <a:t>Oak Ridge, TN</a:t>
             </a:r>
-            <a:endParaRPr lang="en-US" sz="860" dirty="0"/>
+            <a:endParaRPr lang="en-US" sz="863" dirty="0"/>
           </a:p>
         </p:txBody>
       </p:sp>
       <p:sp>
         <p:nvSpPr>
-          <p:cNvPr id="116" name="[Layer 2: Layer #2 - IO cities] Pin - Chicago, IL"/>
+          <p:cNvPr id="119" name="[Layer 1: Layer #1 - US ITER cities] Company label - Example partner 4"/>
+          <p:cNvSpPr/>
+          <p:nvPr/>
+        </p:nvSpPr>
+        <p:spPr>
+          <a:xfrm>
+            <a:off x="8670183" y="4138743"/>
+            <a:ext cx="770954" cy="104585"/>
+          </a:xfrm>
+          <a:prstGeom prst="rect">
+            <a:avLst/>
+          </a:prstGeom>
+          <a:noFill/>
+          <a:ln/>
+        </p:spPr>
+        <p:txBody>
+          <a:bodyPr wrap="square" lIns="0" tIns="0" rIns="0" bIns="0" rtlCol="0" anchor="t"/>
+          <a:lstStyle/>
+          <a:p>
+            <a:pPr algn="l" indent="0" marL="0">
+              <a:buNone/>
+            </a:pPr>
+            <a:r>
+              <a:rPr lang="en-US" sz="675" b="1" dirty="0">
+                <a:solidFill>
+                  <a:srgbClr val="00454D"/>
+                </a:solidFill>
+                <a:latin typeface="Arial" pitchFamily="34" charset="0"/>
+                <a:ea typeface="Arial" pitchFamily="34" charset="-122"/>
+                <a:cs typeface="Arial" pitchFamily="34" charset="-120"/>
+              </a:rPr>
+              <a:t>Example partner 4</a:t>
+            </a:r>
+            <a:endParaRPr lang="en-US" sz="675" dirty="0"/>
+          </a:p>
+        </p:txBody>
+      </p:sp>
+      <p:sp>
+        <p:nvSpPr>
+          <p:cNvPr id="120" name="[Layer 2: Layer #2 - IO cities] Pin - Chicago, IL"/>
           <p:cNvSpPr/>
           <p:nvPr/>
         </p:nvSpPr>
@@ -31644,14 +31800,14 @@
       </p:sp>
       <p:sp>
         <p:nvSpPr>
-          <p:cNvPr id="117" name="[Layer 2: Layer #2 - IO cities] Location label - Chicago, IL"/>
+          <p:cNvPr id="121" name="[Layer 2: Layer #2 - IO cities] City label - Chicago, IL"/>
           <p:cNvSpPr/>
           <p:nvPr/>
         </p:nvSpPr>
         <p:spPr>
           <a:xfrm>
-            <a:off x="7996202" y="2894127"/>
-            <a:ext cx="754380" cy="182880"/>
+            <a:off x="8003822" y="2821213"/>
+            <a:ext cx="612354" cy="133636"/>
           </a:xfrm>
           <a:prstGeom prst="rect">
             <a:avLst/>
@@ -31660,14 +31816,14 @@
           <a:ln/>
         </p:spPr>
         <p:txBody>
-          <a:bodyPr wrap="square" lIns="0" tIns="0" rIns="0" bIns="0" rtlCol="0" anchor="ctr"/>
+          <a:bodyPr wrap="square" lIns="0" tIns="0" rIns="0" bIns="0" rtlCol="0" anchor="t"/>
           <a:lstStyle/>
           <a:p>
             <a:pPr algn="l" indent="0" marL="0">
               <a:buNone/>
             </a:pPr>
             <a:r>
-              <a:rPr lang="en-US" sz="860" b="1" dirty="0">
+              <a:rPr lang="en-US" sz="863" b="1" dirty="0">
                 <a:solidFill>
                   <a:srgbClr val="373A36"/>
                 </a:solidFill>
@@ -31677,13 +31833,52 @@
               </a:rPr>
               <a:t>Chicago, IL</a:t>
             </a:r>
-            <a:endParaRPr lang="en-US" sz="860" dirty="0"/>
+            <a:endParaRPr lang="en-US" sz="863" dirty="0"/>
           </a:p>
         </p:txBody>
       </p:sp>
       <p:sp>
         <p:nvSpPr>
-          <p:cNvPr id="118" name="[Layer 2: Layer #2 - IO cities] Pin - Atlanta, GA"/>
+          <p:cNvPr id="122" name="[Layer 2: Layer #2 - IO cities] Company label - Example partner 5"/>
+          <p:cNvSpPr/>
+          <p:nvPr/>
+        </p:nvSpPr>
+        <p:spPr>
+          <a:xfrm>
+            <a:off x="8003822" y="2969137"/>
+            <a:ext cx="770954" cy="104585"/>
+          </a:xfrm>
+          <a:prstGeom prst="rect">
+            <a:avLst/>
+          </a:prstGeom>
+          <a:noFill/>
+          <a:ln/>
+        </p:spPr>
+        <p:txBody>
+          <a:bodyPr wrap="square" lIns="0" tIns="0" rIns="0" bIns="0" rtlCol="0" anchor="t"/>
+          <a:lstStyle/>
+          <a:p>
+            <a:pPr algn="l" indent="0" marL="0">
+              <a:buNone/>
+            </a:pPr>
+            <a:r>
+              <a:rPr lang="en-US" sz="675" b="1" dirty="0">
+                <a:solidFill>
+                  <a:srgbClr val="00454D"/>
+                </a:solidFill>
+                <a:latin typeface="Arial" pitchFamily="34" charset="0"/>
+                <a:ea typeface="Arial" pitchFamily="34" charset="-122"/>
+                <a:cs typeface="Arial" pitchFamily="34" charset="-120"/>
+              </a:rPr>
+              <a:t>Example partner 5</a:t>
+            </a:r>
+            <a:endParaRPr lang="en-US" sz="675" dirty="0"/>
+          </a:p>
+        </p:txBody>
+      </p:sp>
+      <p:sp>
+        <p:nvSpPr>
+          <p:cNvPr id="123" name="[Layer 2: Layer #2 - IO cities] Pin - Atlanta, GA"/>
           <p:cNvSpPr/>
           <p:nvPr/>
         </p:nvSpPr>
@@ -31708,14 +31903,14 @@
       </p:sp>
       <p:sp>
         <p:nvSpPr>
-          <p:cNvPr id="119" name="[Layer 2: Layer #2 - IO cities] Location label - Atlanta, GA"/>
+          <p:cNvPr id="124" name="[Layer 2: Layer #2 - IO cities] City label - Atlanta, GA"/>
           <p:cNvSpPr/>
           <p:nvPr/>
         </p:nvSpPr>
         <p:spPr>
           <a:xfrm>
-            <a:off x="8700838" y="4537656"/>
-            <a:ext cx="754380" cy="182880"/>
+            <a:off x="8708458" y="4464743"/>
+            <a:ext cx="666772" cy="133636"/>
           </a:xfrm>
           <a:prstGeom prst="rect">
             <a:avLst/>
@@ -31724,14 +31919,14 @@
           <a:ln/>
         </p:spPr>
         <p:txBody>
-          <a:bodyPr wrap="square" lIns="0" tIns="0" rIns="0" bIns="0" rtlCol="0" anchor="ctr"/>
+          <a:bodyPr wrap="square" lIns="0" tIns="0" rIns="0" bIns="0" rtlCol="0" anchor="t"/>
           <a:lstStyle/>
           <a:p>
             <a:pPr algn="l" indent="0" marL="0">
               <a:buNone/>
             </a:pPr>
             <a:r>
-              <a:rPr lang="en-US" sz="860" b="1" dirty="0">
+              <a:rPr lang="en-US" sz="863" b="1" dirty="0">
                 <a:solidFill>
                   <a:srgbClr val="373A36"/>
                 </a:solidFill>
@@ -31741,13 +31936,52 @@
               </a:rPr>
               <a:t>Atlanta, GA</a:t>
             </a:r>
-            <a:endParaRPr lang="en-US" sz="860" dirty="0"/>
+            <a:endParaRPr lang="en-US" sz="863" dirty="0"/>
           </a:p>
         </p:txBody>
       </p:sp>
       <p:sp>
         <p:nvSpPr>
-          <p:cNvPr id="120" name="[Layer 2: Layer #2 - IO cities] Pin - Washington, DC"/>
+          <p:cNvPr id="125" name="[Layer 2: Layer #2 - IO cities] Company label - Example partner 6"/>
+          <p:cNvSpPr/>
+          <p:nvPr/>
+        </p:nvSpPr>
+        <p:spPr>
+          <a:xfrm>
+            <a:off x="8708458" y="4612666"/>
+            <a:ext cx="770954" cy="104585"/>
+          </a:xfrm>
+          <a:prstGeom prst="rect">
+            <a:avLst/>
+          </a:prstGeom>
+          <a:noFill/>
+          <a:ln/>
+        </p:spPr>
+        <p:txBody>
+          <a:bodyPr wrap="square" lIns="0" tIns="0" rIns="0" bIns="0" rtlCol="0" anchor="t"/>
+          <a:lstStyle/>
+          <a:p>
+            <a:pPr algn="l" indent="0" marL="0">
+              <a:buNone/>
+            </a:pPr>
+            <a:r>
+              <a:rPr lang="en-US" sz="675" b="1" dirty="0">
+                <a:solidFill>
+                  <a:srgbClr val="00454D"/>
+                </a:solidFill>
+                <a:latin typeface="Arial" pitchFamily="34" charset="0"/>
+                <a:ea typeface="Arial" pitchFamily="34" charset="-122"/>
+                <a:cs typeface="Arial" pitchFamily="34" charset="-120"/>
+              </a:rPr>
+              <a:t>Example partner 6</a:t>
+            </a:r>
+            <a:endParaRPr lang="en-US" sz="675" dirty="0"/>
+          </a:p>
+        </p:txBody>
+      </p:sp>
+      <p:sp>
+        <p:nvSpPr>
+          <p:cNvPr id="126" name="[Layer 2: Layer #2 - IO cities] Pin - Washington, DC"/>
           <p:cNvSpPr/>
           <p:nvPr/>
         </p:nvSpPr>
@@ -31772,14 +32006,60 @@
       </p:sp>
       <p:sp>
         <p:nvSpPr>
-          <p:cNvPr id="121" name="[Layer 2: Layer #2 - IO cities] Location label - Washington, DC"/>
+          <p:cNvPr id="127" name="[Layer 2: Layer #2 - IO cities] Leader line 1 - Washington, DC"/>
           <p:cNvSpPr/>
           <p:nvPr/>
         </p:nvSpPr>
         <p:spPr>
           <a:xfrm>
-            <a:off x="9733389" y="3272425"/>
-            <a:ext cx="960120" cy="182880"/>
+            <a:off x="9645759" y="3325765"/>
+            <a:ext cx="95250" cy="914"/>
+          </a:xfrm>
+          <a:prstGeom prst="line">
+            <a:avLst/>
+          </a:prstGeom>
+          <a:noFill/>
+          <a:ln w="9525">
+            <a:solidFill>
+              <a:srgbClr val="526966"/>
+            </a:solidFill>
+            <a:prstDash val="solid"/>
+          </a:ln>
+        </p:spPr>
+      </p:sp>
+      <p:sp>
+        <p:nvSpPr>
+          <p:cNvPr id="128" name="[Layer 2: Layer #2 - IO cities] Leader line 2 - Washington, DC"/>
+          <p:cNvSpPr/>
+          <p:nvPr/>
+        </p:nvSpPr>
+        <p:spPr>
+          <a:xfrm>
+            <a:off x="9741009" y="3325765"/>
+            <a:ext cx="914" cy="914"/>
+          </a:xfrm>
+          <a:prstGeom prst="line">
+            <a:avLst/>
+          </a:prstGeom>
+          <a:noFill/>
+          <a:ln w="9525">
+            <a:solidFill>
+              <a:srgbClr val="526966"/>
+            </a:solidFill>
+            <a:prstDash val="solid"/>
+          </a:ln>
+        </p:spPr>
+      </p:sp>
+      <p:sp>
+        <p:nvSpPr>
+          <p:cNvPr id="129" name="[Layer 2: Layer #2 - IO cities] City label - Washington, DC"/>
+          <p:cNvSpPr/>
+          <p:nvPr/>
+        </p:nvSpPr>
+        <p:spPr>
+          <a:xfrm>
+            <a:off x="9741009" y="3199511"/>
+            <a:ext cx="857236" cy="133636"/>
           </a:xfrm>
           <a:prstGeom prst="rect">
             <a:avLst/>
@@ -31788,14 +32068,14 @@
           <a:ln/>
         </p:spPr>
         <p:txBody>
-          <a:bodyPr wrap="square" lIns="0" tIns="0" rIns="0" bIns="0" rtlCol="0" anchor="ctr"/>
+          <a:bodyPr wrap="square" lIns="0" tIns="0" rIns="0" bIns="0" rtlCol="0" anchor="t"/>
           <a:lstStyle/>
           <a:p>
             <a:pPr algn="l" indent="0" marL="0">
               <a:buNone/>
             </a:pPr>
             <a:r>
-              <a:rPr lang="en-US" sz="860" b="1" dirty="0">
+              <a:rPr lang="en-US" sz="863" b="1" dirty="0">
                 <a:solidFill>
                   <a:srgbClr val="373A36"/>
                 </a:solidFill>
@@ -31805,13 +32085,52 @@
               </a:rPr>
               <a:t>Washington, DC</a:t>
             </a:r>
-            <a:endParaRPr lang="en-US" sz="860" dirty="0"/>
+            <a:endParaRPr lang="en-US" sz="863" dirty="0"/>
           </a:p>
         </p:txBody>
       </p:sp>
       <p:sp>
         <p:nvSpPr>
-          <p:cNvPr id="122" name="[Layer 2: Layer #2 - IO cities] Pin - New York, NY"/>
+          <p:cNvPr id="130" name="[Layer 2: Layer #2 - IO cities] Company label - Example partner 7"/>
+          <p:cNvSpPr/>
+          <p:nvPr/>
+        </p:nvSpPr>
+        <p:spPr>
+          <a:xfrm>
+            <a:off x="9741009" y="3347434"/>
+            <a:ext cx="770954" cy="104585"/>
+          </a:xfrm>
+          <a:prstGeom prst="rect">
+            <a:avLst/>
+          </a:prstGeom>
+          <a:noFill/>
+          <a:ln/>
+        </p:spPr>
+        <p:txBody>
+          <a:bodyPr wrap="square" lIns="0" tIns="0" rIns="0" bIns="0" rtlCol="0" anchor="t"/>
+          <a:lstStyle/>
+          <a:p>
+            <a:pPr algn="l" indent="0" marL="0">
+              <a:buNone/>
+            </a:pPr>
+            <a:r>
+              <a:rPr lang="en-US" sz="675" b="1" dirty="0">
+                <a:solidFill>
+                  <a:srgbClr val="00454D"/>
+                </a:solidFill>
+                <a:latin typeface="Arial" pitchFamily="34" charset="0"/>
+                <a:ea typeface="Arial" pitchFamily="34" charset="-122"/>
+                <a:cs typeface="Arial" pitchFamily="34" charset="-120"/>
+              </a:rPr>
+              <a:t>Example partner 7</a:t>
+            </a:r>
+            <a:endParaRPr lang="en-US" sz="675" dirty="0"/>
+          </a:p>
+        </p:txBody>
+      </p:sp>
+      <p:sp>
+        <p:nvSpPr>
+          <p:cNvPr id="131" name="[Layer 2: Layer #2 - IO cities] Pin - New York, NY"/>
           <p:cNvSpPr/>
           <p:nvPr/>
         </p:nvSpPr>
@@ -31836,14 +32155,14 @@
       </p:sp>
       <p:sp>
         <p:nvSpPr>
-          <p:cNvPr id="123" name="[Layer 2: Layer #2 - IO cities] Location label - New York, NY"/>
+          <p:cNvPr id="132" name="[Layer 2: Layer #2 - IO cities] City label - New York, NY"/>
           <p:cNvSpPr/>
           <p:nvPr/>
         </p:nvSpPr>
         <p:spPr>
           <a:xfrm>
-            <a:off x="10121668" y="2798901"/>
-            <a:ext cx="822960" cy="182880"/>
+            <a:off x="10129288" y="2725987"/>
+            <a:ext cx="696248" cy="133636"/>
           </a:xfrm>
           <a:prstGeom prst="rect">
             <a:avLst/>
@@ -31852,14 +32171,14 @@
           <a:ln/>
         </p:spPr>
         <p:txBody>
-          <a:bodyPr wrap="square" lIns="0" tIns="0" rIns="0" bIns="0" rtlCol="0" anchor="ctr"/>
+          <a:bodyPr wrap="square" lIns="0" tIns="0" rIns="0" bIns="0" rtlCol="0" anchor="t"/>
           <a:lstStyle/>
           <a:p>
             <a:pPr algn="l" indent="0" marL="0">
               <a:buNone/>
             </a:pPr>
             <a:r>
-              <a:rPr lang="en-US" sz="860" b="1" dirty="0">
+              <a:rPr lang="en-US" sz="863" b="1" dirty="0">
                 <a:solidFill>
                   <a:srgbClr val="373A36"/>
                 </a:solidFill>
@@ -31869,13 +32188,52 @@
               </a:rPr>
               <a:t>New York, NY</a:t>
             </a:r>
-            <a:endParaRPr lang="en-US" sz="860" dirty="0"/>
+            <a:endParaRPr lang="en-US" sz="863" dirty="0"/>
           </a:p>
         </p:txBody>
       </p:sp>
       <p:sp>
         <p:nvSpPr>
-          <p:cNvPr id="124" name="Legend background"/>
+          <p:cNvPr id="133" name="[Layer 2: Layer #2 - IO cities] Company label - Example partner 8"/>
+          <p:cNvSpPr/>
+          <p:nvPr/>
+        </p:nvSpPr>
+        <p:spPr>
+          <a:xfrm>
+            <a:off x="10129288" y="2873910"/>
+            <a:ext cx="770954" cy="104585"/>
+          </a:xfrm>
+          <a:prstGeom prst="rect">
+            <a:avLst/>
+          </a:prstGeom>
+          <a:noFill/>
+          <a:ln/>
+        </p:spPr>
+        <p:txBody>
+          <a:bodyPr wrap="square" lIns="0" tIns="0" rIns="0" bIns="0" rtlCol="0" anchor="t"/>
+          <a:lstStyle/>
+          <a:p>
+            <a:pPr algn="l" indent="0" marL="0">
+              <a:buNone/>
+            </a:pPr>
+            <a:r>
+              <a:rPr lang="en-US" sz="675" b="1" dirty="0">
+                <a:solidFill>
+                  <a:srgbClr val="00454D"/>
+                </a:solidFill>
+                <a:latin typeface="Arial" pitchFamily="34" charset="0"/>
+                <a:ea typeface="Arial" pitchFamily="34" charset="-122"/>
+                <a:cs typeface="Arial" pitchFamily="34" charset="-120"/>
+              </a:rPr>
+              <a:t>Example partner 8</a:t>
+            </a:r>
+            <a:endParaRPr lang="en-US" sz="675" dirty="0"/>
+          </a:p>
+        </p:txBody>
+      </p:sp>
+      <p:sp>
+        <p:nvSpPr>
+          <p:cNvPr id="134" name="Legend background"/>
           <p:cNvSpPr/>
           <p:nvPr/>
         </p:nvSpPr>
@@ -31900,7 +32258,7 @@
       </p:sp>
       <p:sp>
         <p:nvSpPr>
-          <p:cNvPr id="125" name="Legend location symbol"/>
+          <p:cNvPr id="135" name="Legend location symbol"/>
           <p:cNvSpPr/>
           <p:nvPr/>
         </p:nvSpPr>
@@ -31927,7 +32285,7 @@
       </p:sp>
       <p:sp>
         <p:nvSpPr>
-          <p:cNvPr id="126" name="Legend location count"/>
+          <p:cNvPr id="136" name="Legend location count"/>
           <p:cNvSpPr/>
           <p:nvPr/>
         </p:nvSpPr>
@@ -31966,7 +32324,7 @@
       </p:sp>
       <p:sp>
         <p:nvSpPr>
-          <p:cNvPr id="127" name="Legend boundary symbol"/>
+          <p:cNvPr id="137" name="Legend boundary symbol"/>
           <p:cNvSpPr/>
           <p:nvPr/>
         </p:nvSpPr>
@@ -31989,7 +32347,7 @@
       </p:sp>
       <p:sp>
         <p:nvSpPr>
-          <p:cNvPr id="128" name="Legend geography source"/>
+          <p:cNvPr id="138" name="Legend geography source"/>
           <p:cNvSpPr/>
           <p:nvPr/>
         </p:nvSpPr>

</xml_diff>